<commit_message>
Add equations, a setup check and Codex guidance; Claude Code first
- tools/equations.py: LaTeX to PNG, SVG and TeX with matplotlib mathtext (Computer Modern, display-style fractions, & alignment)
- rules/equations.md (IEEE notation, making and placing equations, SymPy check) and Deck.equation() for an equation-box slide; the example Key Idea slide uses it
- check_setup.py and requirements.txt: check Python packages, fonts, figstyle and a slide renderer, and install missing packages with --install
- AGENTS.md for Codex replaces chatgpt/INSTRUCTIONS.md; SKILL.md, README and rules updated

Co-Authored-By: Claude Opus 5.5 <noreply@anthropic.com>
</commit_message>
<xml_diff>
--- a/example/demo_amp.pptx
+++ b/example/demo_amp.pptx
@@ -976,7 +976,7 @@
                 <a:ea typeface="Noto Sans KR"/>
                 <a:cs typeface="Arial"/>
               </a:rPr>
-              <a:t>핵심은 전류를 잡음을 정하는 입력단에만 쓰는 것입니다.</a:t>
+              <a:t>잡음은 입력 소자의 g_m 에 반비례하고, g_m 은 전류에 비례합니다.</a:t>
             </a:r>
           </a:p>
           <a:p>
@@ -994,7 +994,7 @@
                 <a:ea typeface="Noto Sans KR"/>
                 <a:cs typeface="Arial"/>
               </a:rPr>
-              <a:t>출력단은 그대로 두어서, 전력은 40 % 늘고 잡음은 35 % 줄었습니다.</a:t>
+              <a:t>그래서 전류를 입력단에만 쓰고 출력단은 그대로 두었습니다. 전력은 40 % 늘고 잡음은 35 % 줄었습니다.</a:t>
             </a:r>
           </a:p>
         </p:txBody>
@@ -7235,7 +7235,29 @@
                 <a:ea typeface="Noto Sans KR"/>
                 <a:cs typeface="Arial"/>
               </a:rPr>
-              <a:t>입력단에만 전류 집중 — 출력단은 최소 전류 유지</a:t>
+              <a:t>입력단 전류로 g</a:t>
+            </a:r>
+            <a:r>
+              <a:rPr sz="2000" b="0" lang="en-US" baseline="-25000">
+                <a:solidFill>
+                  <a:srgbClr val="4A4A4A"/>
+                </a:solidFill>
+                <a:latin typeface="Arial"/>
+                <a:ea typeface="Noto Sans KR"/>
+                <a:cs typeface="Arial"/>
+              </a:rPr>
+              <a:t>m</a:t>
+            </a:r>
+            <a:r>
+              <a:rPr sz="2000" b="0" lang="ko-KR">
+                <a:solidFill>
+                  <a:srgbClr val="4A4A4A"/>
+                </a:solidFill>
+                <a:latin typeface="Arial"/>
+                <a:ea typeface="Noto Sans KR"/>
+                <a:cs typeface="Arial"/>
+              </a:rPr>
+              <a:t> 을 키워 잡음 감소 — 출력단은 최소 전류 유지</a:t>
             </a:r>
           </a:p>
         </p:txBody>
@@ -7290,6 +7312,126 @@
         <p:spPr>
           <a:xfrm>
             <a:off x="812800" y="1611630"/>
+            <a:ext cx="10566400" cy="1866902"/>
+          </a:xfrm>
+          <a:prstGeom prst="roundRect">
+            <a:avLst>
+              <a:gd name="adj" fmla="val 2721"/>
+            </a:avLst>
+          </a:prstGeom>
+          <a:solidFill>
+            <a:srgbClr val="F5F5F3"/>
+          </a:solidFill>
+          <a:ln w="9525">
+            <a:solidFill>
+              <a:srgbClr val="E5E5E3"/>
+            </a:solidFill>
+          </a:ln>
+        </p:spPr>
+        <p:txBody>
+          <a:bodyPr rtlCol="0" anchor="ctr"/>
+          <a:lstStyle/>
+          <a:p>
+            <a:pPr algn="ctr"/>
+          </a:p>
+        </p:txBody>
+      </p:sp>
+      <p:pic>
+        <p:nvPicPr>
+          <p:cNvPr id="6" name="Picture 5" descr="equation"/>
+          <p:cNvPicPr>
+            <a:picLocks noChangeAspect="1"/>
+          </p:cNvPicPr>
+          <p:nvPr/>
+        </p:nvPicPr>
+        <p:blipFill>
+          <a:blip r:embed="rId2"/>
+          <a:stretch>
+            <a:fillRect/>
+          </a:stretch>
+        </p:blipFill>
+        <p:spPr>
+          <a:xfrm>
+            <a:off x="5615939" y="1840230"/>
+            <a:ext cx="960122" cy="1059182"/>
+          </a:xfrm>
+          <a:prstGeom prst="rect">
+            <a:avLst/>
+          </a:prstGeom>
+        </p:spPr>
+      </p:pic>
+      <p:sp>
+        <p:nvSpPr>
+          <p:cNvPr id="7" name="TextBox 6"/>
+          <p:cNvSpPr txBox="1"/>
+          <p:nvPr/>
+        </p:nvSpPr>
+        <p:spPr>
+          <a:xfrm>
+            <a:off x="1041400" y="3001012"/>
+            <a:ext cx="10109200" cy="248920"/>
+          </a:xfrm>
+          <a:prstGeom prst="rect">
+            <a:avLst/>
+          </a:prstGeom>
+          <a:noFill/>
+        </p:spPr>
+        <p:txBody>
+          <a:bodyPr wrap="square" lIns="0" rIns="0" tIns="0" bIns="0" anchor="t">
+            <a:noAutofit/>
+          </a:bodyPr>
+          <a:lstStyle/>
+          <a:p>
+            <a:pPr algn="ctr">
+              <a:lnSpc>
+                <a:spcPts val="1959"/>
+              </a:lnSpc>
+            </a:pPr>
+            <a:r>
+              <a:rPr sz="1400" b="0" lang="ko-KR">
+                <a:solidFill>
+                  <a:srgbClr val="4A4A4A"/>
+                </a:solidFill>
+                <a:latin typeface="Arial"/>
+                <a:ea typeface="Noto Sans KR"/>
+                <a:cs typeface="Arial"/>
+              </a:rPr>
+              <a:t>k 볼츠만 상수, T 절대 온도, γ 잡음 계수, V</a:t>
+            </a:r>
+            <a:r>
+              <a:rPr sz="1400" b="0" lang="en-US" baseline="-25000">
+                <a:solidFill>
+                  <a:srgbClr val="4A4A4A"/>
+                </a:solidFill>
+                <a:latin typeface="Arial"/>
+                <a:ea typeface="Noto Sans KR"/>
+                <a:cs typeface="Arial"/>
+              </a:rPr>
+              <a:t>ov</a:t>
+            </a:r>
+            <a:r>
+              <a:rPr sz="1400" b="0" lang="ko-KR">
+                <a:solidFill>
+                  <a:srgbClr val="4A4A4A"/>
+                </a:solidFill>
+                <a:latin typeface="Arial"/>
+                <a:ea typeface="Noto Sans KR"/>
+                <a:cs typeface="Arial"/>
+              </a:rPr>
+              <a:t> overdrive 전압</a:t>
+            </a:r>
+          </a:p>
+        </p:txBody>
+      </p:sp>
+      <p:sp>
+        <p:nvSpPr>
+          <p:cNvPr id="8" name="Rounded Rectangle 7"/>
+          <p:cNvSpPr/>
+          <p:nvPr/>
+        </p:nvSpPr>
+        <p:spPr>
+          <a:xfrm>
+            <a:off x="812800" y="3732532"/>
             <a:ext cx="3386667" cy="1379220"/>
           </a:xfrm>
           <a:prstGeom prst="roundRect">
@@ -7316,13 +7458,13 @@
       </p:sp>
       <p:sp>
         <p:nvSpPr>
-          <p:cNvPr id="6" name="TextBox 5"/>
+          <p:cNvPr id="9" name="TextBox 8"/>
           <p:cNvSpPr txBox="1"/>
           <p:nvPr/>
         </p:nvSpPr>
         <p:spPr>
           <a:xfrm>
-            <a:off x="1041400" y="1840230"/>
+            <a:off x="1041400" y="3961132"/>
             <a:ext cx="2929467" cy="284480"/>
           </a:xfrm>
           <a:prstGeom prst="rect">
@@ -7357,13 +7499,13 @@
       </p:sp>
       <p:sp>
         <p:nvSpPr>
-          <p:cNvPr id="7" name="TextBox 6"/>
+          <p:cNvPr id="10" name="TextBox 9"/>
           <p:cNvSpPr txBox="1"/>
           <p:nvPr/>
         </p:nvSpPr>
         <p:spPr>
           <a:xfrm>
-            <a:off x="1041400" y="2200910"/>
+            <a:off x="1041400" y="4321812"/>
             <a:ext cx="2929467" cy="561340"/>
           </a:xfrm>
           <a:prstGeom prst="rect">
@@ -7445,13 +7587,13 @@
       </p:sp>
       <p:sp>
         <p:nvSpPr>
-          <p:cNvPr id="8" name="Rounded Rectangle 7"/>
+          <p:cNvPr id="11" name="Rounded Rectangle 10"/>
           <p:cNvSpPr/>
           <p:nvPr/>
         </p:nvSpPr>
         <p:spPr>
           <a:xfrm>
-            <a:off x="4402667" y="1611630"/>
+            <a:off x="4402667" y="3732532"/>
             <a:ext cx="3386667" cy="1379220"/>
           </a:xfrm>
           <a:prstGeom prst="roundRect">
@@ -7478,13 +7620,13 @@
       </p:sp>
       <p:sp>
         <p:nvSpPr>
-          <p:cNvPr id="9" name="TextBox 8"/>
+          <p:cNvPr id="12" name="TextBox 11"/>
           <p:cNvSpPr txBox="1"/>
           <p:nvPr/>
         </p:nvSpPr>
         <p:spPr>
           <a:xfrm>
-            <a:off x="4631267" y="1840230"/>
+            <a:off x="4631267" y="3961132"/>
             <a:ext cx="2929467" cy="284480"/>
           </a:xfrm>
           <a:prstGeom prst="rect">
@@ -7519,13 +7661,13 @@
       </p:sp>
       <p:sp>
         <p:nvSpPr>
-          <p:cNvPr id="10" name="TextBox 9"/>
+          <p:cNvPr id="13" name="TextBox 12"/>
           <p:cNvSpPr txBox="1"/>
           <p:nvPr/>
         </p:nvSpPr>
         <p:spPr>
           <a:xfrm>
-            <a:off x="4631267" y="2200910"/>
+            <a:off x="4631267" y="4321812"/>
             <a:ext cx="2929467" cy="561340"/>
           </a:xfrm>
           <a:prstGeom prst="rect">
@@ -7585,13 +7727,13 @@
       </p:sp>
       <p:sp>
         <p:nvSpPr>
-          <p:cNvPr id="11" name="Rounded Rectangle 10"/>
+          <p:cNvPr id="14" name="Rounded Rectangle 13"/>
           <p:cNvSpPr/>
           <p:nvPr/>
         </p:nvSpPr>
         <p:spPr>
           <a:xfrm>
-            <a:off x="7992533" y="1611630"/>
+            <a:off x="7992533" y="3732532"/>
             <a:ext cx="3386667" cy="1379220"/>
           </a:xfrm>
           <a:prstGeom prst="roundRect">
@@ -7618,13 +7760,13 @@
       </p:sp>
       <p:sp>
         <p:nvSpPr>
-          <p:cNvPr id="12" name="TextBox 11"/>
+          <p:cNvPr id="15" name="TextBox 14"/>
           <p:cNvSpPr txBox="1"/>
           <p:nvPr/>
         </p:nvSpPr>
         <p:spPr>
           <a:xfrm>
-            <a:off x="8221133" y="1840230"/>
+            <a:off x="8221133" y="3961132"/>
             <a:ext cx="2929467" cy="284480"/>
           </a:xfrm>
           <a:prstGeom prst="rect">
@@ -7659,13 +7801,13 @@
       </p:sp>
       <p:sp>
         <p:nvSpPr>
-          <p:cNvPr id="13" name="TextBox 12"/>
+          <p:cNvPr id="16" name="TextBox 15"/>
           <p:cNvSpPr txBox="1"/>
           <p:nvPr/>
         </p:nvSpPr>
         <p:spPr>
           <a:xfrm>
-            <a:off x="8221133" y="2200910"/>
+            <a:off x="8221133" y="4321812"/>
             <a:ext cx="2929467" cy="561340"/>
           </a:xfrm>
           <a:prstGeom prst="rect">
@@ -7725,7 +7867,7 @@
       </p:sp>
       <p:sp>
         <p:nvSpPr>
-          <p:cNvPr id="14" name="TextBox 13"/>
+          <p:cNvPr id="17" name="TextBox 16"/>
           <p:cNvSpPr txBox="1"/>
           <p:nvPr/>
         </p:nvSpPr>

</xml_diff>

<commit_message>
Use MathJax for equations, the same engine as the original decks
- tools/mathjax/ (render.cjs, package.json, package-lock.json): MathJax 3 pinned to mathjax-full 3.2.2; glyphs are drawn as paths, so no fonts are needed and every PC gets the same SVG
- tools/equations.py now renders through MathJax: SVG at the IEEE 10 pt body size with a 252 pt column-width warning, PNG at 1.6x (16 pt) via PyMuPDF for slides, and the TeX source with a real aligned environment; the matplotlib engine is removed
- check_setup.py checks Node.js and MathJax and runs npm ci with --install; requirements.txt adds PyMuPDF; rules, SKILL.md and README updated; the example equation slide redrawn

Co-Authored-By: Claude Opus 5.5 <noreply@anthropic.com>
</commit_message>
<xml_diff>
--- a/example/demo_amp.pptx
+++ b/example/demo_amp.pptx
@@ -7312,11 +7312,11 @@
         <p:spPr>
           <a:xfrm>
             <a:off x="812800" y="1611630"/>
-            <a:ext cx="10566400" cy="1866902"/>
+            <a:ext cx="10566400" cy="1776986"/>
           </a:xfrm>
           <a:prstGeom prst="roundRect">
             <a:avLst>
-              <a:gd name="adj" fmla="val 2721"/>
+              <a:gd name="adj" fmla="val 2858"/>
             </a:avLst>
           </a:prstGeom>
           <a:solidFill>
@@ -7352,8 +7352,8 @@
         </p:blipFill>
         <p:spPr>
           <a:xfrm>
-            <a:off x="5615939" y="1840230"/>
-            <a:ext cx="960122" cy="1059182"/>
+            <a:off x="5567933" y="1840230"/>
+            <a:ext cx="1056134" cy="969266"/>
           </a:xfrm>
           <a:prstGeom prst="rect">
             <a:avLst/>
@@ -7368,7 +7368,7 @@
         </p:nvSpPr>
         <p:spPr>
           <a:xfrm>
-            <a:off x="1041400" y="3001012"/>
+            <a:off x="1041400" y="2911096"/>
             <a:ext cx="10109200" cy="248920"/>
           </a:xfrm>
           <a:prstGeom prst="rect">
@@ -7431,7 +7431,7 @@
         </p:nvSpPr>
         <p:spPr>
           <a:xfrm>
-            <a:off x="812800" y="3732532"/>
+            <a:off x="812800" y="3642616"/>
             <a:ext cx="3386667" cy="1379220"/>
           </a:xfrm>
           <a:prstGeom prst="roundRect">
@@ -7464,7 +7464,7 @@
         </p:nvSpPr>
         <p:spPr>
           <a:xfrm>
-            <a:off x="1041400" y="3961132"/>
+            <a:off x="1041400" y="3871216"/>
             <a:ext cx="2929467" cy="284480"/>
           </a:xfrm>
           <a:prstGeom prst="rect">
@@ -7505,7 +7505,7 @@
         </p:nvSpPr>
         <p:spPr>
           <a:xfrm>
-            <a:off x="1041400" y="4321812"/>
+            <a:off x="1041400" y="4231896"/>
             <a:ext cx="2929467" cy="561340"/>
           </a:xfrm>
           <a:prstGeom prst="rect">
@@ -7593,7 +7593,7 @@
         </p:nvSpPr>
         <p:spPr>
           <a:xfrm>
-            <a:off x="4402667" y="3732532"/>
+            <a:off x="4402667" y="3642616"/>
             <a:ext cx="3386667" cy="1379220"/>
           </a:xfrm>
           <a:prstGeom prst="roundRect">
@@ -7626,7 +7626,7 @@
         </p:nvSpPr>
         <p:spPr>
           <a:xfrm>
-            <a:off x="4631267" y="3961132"/>
+            <a:off x="4631267" y="3871216"/>
             <a:ext cx="2929467" cy="284480"/>
           </a:xfrm>
           <a:prstGeom prst="rect">
@@ -7667,7 +7667,7 @@
         </p:nvSpPr>
         <p:spPr>
           <a:xfrm>
-            <a:off x="4631267" y="4321812"/>
+            <a:off x="4631267" y="4231896"/>
             <a:ext cx="2929467" cy="561340"/>
           </a:xfrm>
           <a:prstGeom prst="rect">
@@ -7733,7 +7733,7 @@
         </p:nvSpPr>
         <p:spPr>
           <a:xfrm>
-            <a:off x="7992533" y="3732532"/>
+            <a:off x="7992533" y="3642616"/>
             <a:ext cx="3386667" cy="1379220"/>
           </a:xfrm>
           <a:prstGeom prst="roundRect">
@@ -7766,7 +7766,7 @@
         </p:nvSpPr>
         <p:spPr>
           <a:xfrm>
-            <a:off x="8221133" y="3961132"/>
+            <a:off x="8221133" y="3871216"/>
             <a:ext cx="2929467" cy="284480"/>
           </a:xfrm>
           <a:prstGeom prst="rect">
@@ -7807,7 +7807,7 @@
         </p:nvSpPr>
         <p:spPr>
           <a:xfrm>
-            <a:off x="8221133" y="4321812"/>
+            <a:off x="8221133" y="4231896"/>
             <a:ext cx="2929467" cy="561340"/>
           </a:xfrm>
           <a:prstGeom prst="rect">

</xml_diff>